<commit_message>
add: refresh the manual and presentation (android only, with screenshots)
</commit_message>
<xml_diff>
--- a/docs/drive/presentacion/presentacion.pptx
+++ b/docs/drive/presentacion/presentacion.pptx
@@ -2788,6 +2788,10 @@
           </a:solidFill>
           <a:ln/>
         </p:spPr>
+        <p:txBody>
+          <a:bodyPr/>
+          <a:p/>
+        </p:txBody>
       </p:sp>
       <p:sp>
         <p:nvSpPr>
@@ -2974,6 +2978,10 @@
             <a:prstDash val="solid"/>
           </a:ln>
         </p:spPr>
+        <p:txBody>
+          <a:bodyPr/>
+          <a:p/>
+        </p:txBody>
       </p:sp>
       <p:sp>
         <p:nvSpPr>
@@ -3040,6 +3048,10 @@
             <a:prstDash val="solid"/>
           </a:ln>
         </p:spPr>
+        <p:txBody>
+          <a:bodyPr/>
+          <a:p/>
+        </p:txBody>
       </p:sp>
       <p:sp>
         <p:nvSpPr>
@@ -3106,6 +3118,10 @@
             <a:prstDash val="solid"/>
           </a:ln>
         </p:spPr>
+        <p:txBody>
+          <a:bodyPr/>
+          <a:p/>
+        </p:txBody>
       </p:sp>
       <p:sp>
         <p:nvSpPr>
@@ -3140,7 +3156,7 @@
                 <a:ea typeface="Calibri" pitchFamily="34" charset="-122"/>
                 <a:cs typeface="Calibri" pitchFamily="34" charset="-120"/>
               </a:rPr>
-              <a:t>PC &amp; Android</a:t>
+              <a:t>Android</a:t>
             </a:r>
             <a:endParaRPr lang="en-US" sz="1200" dirty="0"/>
           </a:p>
@@ -3172,6 +3188,10 @@
             <a:prstDash val="solid"/>
           </a:ln>
         </p:spPr>
+        <p:txBody>
+          <a:bodyPr/>
+          <a:p/>
+        </p:txBody>
       </p:sp>
       <p:sp>
         <p:nvSpPr>
@@ -3302,6 +3322,10 @@
           </a:solidFill>
           <a:ln/>
         </p:spPr>
+        <p:txBody>
+          <a:bodyPr/>
+          <a:p/>
+        </p:txBody>
       </p:sp>
       <p:sp>
         <p:nvSpPr>
@@ -3915,16 +3939,133 @@
           </a:p>
         </p:txBody>
       </p:sp>
+      <p:sp>
+        <p:nvSpPr>
+          <p:cNvPr id="11" name="Text 8"/>
+          <p:cNvSpPr/>
+          <p:nvPr/>
+        </p:nvSpPr>
+        <p:spPr>
+          <a:xfrm>
+            <a:off x="6400800" y="4709160"/>
+            <a:ext cx="5120640" cy="274320"/>
+          </a:xfrm>
+          <a:prstGeom prst="rect">
+            <a:avLst/>
+          </a:prstGeom>
+          <a:noFill/>
+          <a:ln/>
+        </p:spPr>
+        <p:txBody>
+          <a:bodyPr wrap="square" rtlCol="0" anchor="ctr"/>
+          <a:lstStyle/>
+          <a:p>
+            <a:pPr indent="0" marL="0">
+              <a:buNone/>
+            </a:pPr>
+            <a:r>
+              <a:rPr lang="en-US" sz="1100" i="1" dirty="0">
+                <a:solidFill>
+                  <a:srgbClr val="97A58A"/>
+                </a:solidFill>
+                <a:latin typeface="Calibri" pitchFamily="34" charset="0"/>
+                <a:ea typeface="Calibri" pitchFamily="34" charset="-122"/>
+                <a:cs typeface="Calibri" pitchFamily="34" charset="-120"/>
+              </a:rPr>
+              <a:t>Defiende el último Árbol vivo.</a:t>
+            </a:r>
+            <a:endParaRPr lang="en-US" sz="1100" dirty="0"/>
+          </a:p>
+        </p:txBody>
+      </p:sp>
+      <p:sp>
+        <p:nvSpPr>
+          <p:cNvPr id="12" name="Text 9"/>
+          <p:cNvSpPr/>
+          <p:nvPr/>
+        </p:nvSpPr>
+        <p:spPr>
+          <a:xfrm>
+            <a:off x="640080" y="6419088"/>
+            <a:ext cx="5486400" cy="274320"/>
+          </a:xfrm>
+          <a:prstGeom prst="rect">
+            <a:avLst/>
+          </a:prstGeom>
+          <a:noFill/>
+          <a:ln/>
+        </p:spPr>
+        <p:txBody>
+          <a:bodyPr wrap="square" rtlCol="0" anchor="ctr"/>
+          <a:lstStyle/>
+          <a:p>
+            <a:pPr indent="0" marL="0">
+              <a:buNone/>
+            </a:pPr>
+            <a:r>
+              <a:rPr lang="en-US" sz="900" spc="200" kern="0" dirty="0">
+                <a:solidFill>
+                  <a:srgbClr val="97A58A"/>
+                </a:solidFill>
+                <a:latin typeface="Calibri" pitchFamily="34" charset="0"/>
+                <a:ea typeface="Calibri" pitchFamily="34" charset="-122"/>
+                <a:cs typeface="Calibri" pitchFamily="34" charset="-120"/>
+              </a:rPr>
+              <a:t>DIRTY ROAD</a:t>
+            </a:r>
+            <a:endParaRPr lang="en-US" sz="900" dirty="0"/>
+          </a:p>
+        </p:txBody>
+      </p:sp>
+      <p:sp>
+        <p:nvSpPr>
+          <p:cNvPr id="13" name="Text 10"/>
+          <p:cNvSpPr/>
+          <p:nvPr/>
+        </p:nvSpPr>
+        <p:spPr>
+          <a:xfrm>
+            <a:off x="11155680" y="6419088"/>
+            <a:ext cx="457200" cy="274320"/>
+          </a:xfrm>
+          <a:prstGeom prst="rect">
+            <a:avLst/>
+          </a:prstGeom>
+          <a:noFill/>
+          <a:ln/>
+        </p:spPr>
+        <p:txBody>
+          <a:bodyPr wrap="square" rtlCol="0" anchor="ctr"/>
+          <a:lstStyle/>
+          <a:p>
+            <a:pPr algn="r" indent="0" marL="0">
+              <a:buNone/>
+            </a:pPr>
+            <a:r>
+              <a:rPr lang="en-US" sz="900" dirty="0">
+                <a:solidFill>
+                  <a:srgbClr val="8EC74A"/>
+                </a:solidFill>
+                <a:latin typeface="Calibri" pitchFamily="34" charset="0"/>
+                <a:ea typeface="Calibri" pitchFamily="34" charset="-122"/>
+                <a:cs typeface="Calibri" pitchFamily="34" charset="-120"/>
+              </a:rPr>
+              <a:t>11</a:t>
+            </a:r>
+            <a:endParaRPr lang="en-US" sz="900" dirty="0"/>
+          </a:p>
+        </p:txBody>
+      </p:sp>
       <p:pic>
         <p:nvPicPr>
-          <p:cNvPr id="10" name="Image 0" descr="/home/lite/dirty-road/docs/folleto/assets/etapa_01.png">    </p:cNvPr>
+          <p:cNvPr id="14" name="Picture 13" descr="hud.png"/>
           <p:cNvPicPr>
             <a:picLocks noChangeAspect="1"/>
           </p:cNvPicPr>
           <p:nvPr/>
         </p:nvPicPr>
         <p:blipFill>
-          <a:blip r:embed="rId1"/>
+          <a:blip r:embed="rId4"/>
           <a:stretch>
             <a:fillRect/>
           </a:stretch>
@@ -3939,123 +4080,6 @@
           </a:prstGeom>
         </p:spPr>
       </p:pic>
-      <p:sp>
-        <p:nvSpPr>
-          <p:cNvPr id="11" name="Text 8"/>
-          <p:cNvSpPr/>
-          <p:nvPr/>
-        </p:nvSpPr>
-        <p:spPr>
-          <a:xfrm>
-            <a:off x="6400800" y="4709160"/>
-            <a:ext cx="5120640" cy="274320"/>
-          </a:xfrm>
-          <a:prstGeom prst="rect">
-            <a:avLst/>
-          </a:prstGeom>
-          <a:noFill/>
-          <a:ln/>
-        </p:spPr>
-        <p:txBody>
-          <a:bodyPr wrap="square" rtlCol="0" anchor="ctr"/>
-          <a:lstStyle/>
-          <a:p>
-            <a:pPr indent="0" marL="0">
-              <a:buNone/>
-            </a:pPr>
-            <a:r>
-              <a:rPr lang="en-US" sz="1100" i="1" dirty="0">
-                <a:solidFill>
-                  <a:srgbClr val="97A58A"/>
-                </a:solidFill>
-                <a:latin typeface="Calibri" pitchFamily="34" charset="0"/>
-                <a:ea typeface="Calibri" pitchFamily="34" charset="-122"/>
-                <a:cs typeface="Calibri" pitchFamily="34" charset="-120"/>
-              </a:rPr>
-              <a:t>Defiende el último Árbol vivo.</a:t>
-            </a:r>
-            <a:endParaRPr lang="en-US" sz="1100" dirty="0"/>
-          </a:p>
-        </p:txBody>
-      </p:sp>
-      <p:sp>
-        <p:nvSpPr>
-          <p:cNvPr id="12" name="Text 9"/>
-          <p:cNvSpPr/>
-          <p:nvPr/>
-        </p:nvSpPr>
-        <p:spPr>
-          <a:xfrm>
-            <a:off x="640080" y="6419088"/>
-            <a:ext cx="5486400" cy="274320"/>
-          </a:xfrm>
-          <a:prstGeom prst="rect">
-            <a:avLst/>
-          </a:prstGeom>
-          <a:noFill/>
-          <a:ln/>
-        </p:spPr>
-        <p:txBody>
-          <a:bodyPr wrap="square" rtlCol="0" anchor="ctr"/>
-          <a:lstStyle/>
-          <a:p>
-            <a:pPr indent="0" marL="0">
-              <a:buNone/>
-            </a:pPr>
-            <a:r>
-              <a:rPr lang="en-US" sz="900" spc="200" kern="0" dirty="0">
-                <a:solidFill>
-                  <a:srgbClr val="97A58A"/>
-                </a:solidFill>
-                <a:latin typeface="Calibri" pitchFamily="34" charset="0"/>
-                <a:ea typeface="Calibri" pitchFamily="34" charset="-122"/>
-                <a:cs typeface="Calibri" pitchFamily="34" charset="-120"/>
-              </a:rPr>
-              <a:t>DIRTY ROAD</a:t>
-            </a:r>
-            <a:endParaRPr lang="en-US" sz="900" dirty="0"/>
-          </a:p>
-        </p:txBody>
-      </p:sp>
-      <p:sp>
-        <p:nvSpPr>
-          <p:cNvPr id="13" name="Text 10"/>
-          <p:cNvSpPr/>
-          <p:nvPr/>
-        </p:nvSpPr>
-        <p:spPr>
-          <a:xfrm>
-            <a:off x="11155680" y="6419088"/>
-            <a:ext cx="457200" cy="274320"/>
-          </a:xfrm>
-          <a:prstGeom prst="rect">
-            <a:avLst/>
-          </a:prstGeom>
-          <a:noFill/>
-          <a:ln/>
-        </p:spPr>
-        <p:txBody>
-          <a:bodyPr wrap="square" rtlCol="0" anchor="ctr"/>
-          <a:lstStyle/>
-          <a:p>
-            <a:pPr algn="r" indent="0" marL="0">
-              <a:buNone/>
-            </a:pPr>
-            <a:r>
-              <a:rPr lang="en-US" sz="900" dirty="0">
-                <a:solidFill>
-                  <a:srgbClr val="8EC74A"/>
-                </a:solidFill>
-                <a:latin typeface="Calibri" pitchFamily="34" charset="0"/>
-                <a:ea typeface="Calibri" pitchFamily="34" charset="-122"/>
-                <a:cs typeface="Calibri" pitchFamily="34" charset="-120"/>
-              </a:rPr>
-              <a:t>11</a:t>
-            </a:r>
-            <a:endParaRPr lang="en-US" sz="900" dirty="0"/>
-          </a:p>
-        </p:txBody>
-      </p:sp>
     </p:spTree>
   </p:cSld>
   <p:clrMapOvr>
@@ -4497,6 +4521,10 @@
           </a:solidFill>
           <a:ln/>
         </p:spPr>
+        <p:txBody>
+          <a:bodyPr/>
+          <a:p/>
+        </p:txBody>
       </p:sp>
       <p:sp>
         <p:nvSpPr>
@@ -4556,6 +4584,10 @@
           </a:solidFill>
           <a:ln/>
         </p:spPr>
+        <p:txBody>
+          <a:bodyPr/>
+          <a:p/>
+        </p:txBody>
       </p:sp>
       <p:sp>
         <p:nvSpPr>
@@ -4615,6 +4647,10 @@
           </a:solidFill>
           <a:ln/>
         </p:spPr>
+        <p:txBody>
+          <a:bodyPr/>
+          <a:p/>
+        </p:txBody>
       </p:sp>
       <p:sp>
         <p:nvSpPr>
@@ -4674,6 +4710,10 @@
           </a:solidFill>
           <a:ln/>
         </p:spPr>
+        <p:txBody>
+          <a:bodyPr/>
+          <a:p/>
+        </p:txBody>
       </p:sp>
       <p:sp>
         <p:nvSpPr>
@@ -4733,6 +4773,10 @@
           </a:solidFill>
           <a:ln/>
         </p:spPr>
+        <p:txBody>
+          <a:bodyPr/>
+          <a:p/>
+        </p:txBody>
       </p:sp>
       <p:sp>
         <p:nvSpPr>
@@ -4792,6 +4836,10 @@
           </a:solidFill>
           <a:ln/>
         </p:spPr>
+        <p:txBody>
+          <a:bodyPr/>
+          <a:p/>
+        </p:txBody>
       </p:sp>
       <p:sp>
         <p:nvSpPr>
@@ -4851,6 +4899,10 @@
           </a:solidFill>
           <a:ln/>
         </p:spPr>
+        <p:txBody>
+          <a:bodyPr/>
+          <a:p/>
+        </p:txBody>
       </p:sp>
       <p:sp>
         <p:nvSpPr>
@@ -4910,6 +4962,10 @@
           </a:solidFill>
           <a:ln/>
         </p:spPr>
+        <p:txBody>
+          <a:bodyPr/>
+          <a:p/>
+        </p:txBody>
       </p:sp>
       <p:sp>
         <p:nvSpPr>
@@ -4969,6 +5025,10 @@
           </a:solidFill>
           <a:ln/>
         </p:spPr>
+        <p:txBody>
+          <a:bodyPr/>
+          <a:p/>
+        </p:txBody>
       </p:sp>
       <p:sp>
         <p:nvSpPr>
@@ -5028,6 +5088,10 @@
           </a:solidFill>
           <a:ln/>
         </p:spPr>
+        <p:txBody>
+          <a:bodyPr/>
+          <a:p/>
+        </p:txBody>
       </p:sp>
       <p:sp>
         <p:nvSpPr>
@@ -5321,6 +5385,10 @@
             <a:prstDash val="solid"/>
           </a:ln>
         </p:spPr>
+        <p:txBody>
+          <a:bodyPr/>
+          <a:p/>
+        </p:txBody>
       </p:sp>
       <p:sp>
         <p:nvSpPr>
@@ -5429,6 +5497,10 @@
             <a:prstDash val="solid"/>
           </a:ln>
         </p:spPr>
+        <p:txBody>
+          <a:bodyPr/>
+          <a:p/>
+        </p:txBody>
       </p:sp>
       <p:sp>
         <p:nvSpPr>
@@ -5537,6 +5609,10 @@
             <a:prstDash val="solid"/>
           </a:ln>
         </p:spPr>
+        <p:txBody>
+          <a:bodyPr/>
+          <a:p/>
+        </p:txBody>
       </p:sp>
       <p:sp>
         <p:nvSpPr>
@@ -5833,6 +5909,10 @@
             <a:prstDash val="solid"/>
           </a:ln>
         </p:spPr>
+        <p:txBody>
+          <a:bodyPr/>
+          <a:p/>
+        </p:txBody>
       </p:sp>
       <p:sp>
         <p:nvSpPr>
@@ -5941,6 +6021,10 @@
             <a:prstDash val="solid"/>
           </a:ln>
         </p:spPr>
+        <p:txBody>
+          <a:bodyPr/>
+          <a:p/>
+        </p:txBody>
       </p:sp>
       <p:sp>
         <p:nvSpPr>
@@ -6049,6 +6133,10 @@
             <a:prstDash val="solid"/>
           </a:ln>
         </p:spPr>
+        <p:txBody>
+          <a:bodyPr/>
+          <a:p/>
+        </p:txBody>
       </p:sp>
       <p:sp>
         <p:nvSpPr>
@@ -6260,6 +6348,10 @@
           </a:solidFill>
           <a:ln/>
         </p:spPr>
+        <p:txBody>
+          <a:bodyPr/>
+          <a:p/>
+        </p:txBody>
       </p:sp>
       <p:sp>
         <p:nvSpPr>
@@ -6686,6 +6778,10 @@
             <a:prstDash val="solid"/>
           </a:ln>
         </p:spPr>
+        <p:txBody>
+          <a:bodyPr/>
+          <a:p/>
+        </p:txBody>
       </p:sp>
       <p:sp>
         <p:nvSpPr>
@@ -7770,6 +7866,10 @@
             <a:prstDash val="solid"/>
           </a:ln>
         </p:spPr>
+        <p:txBody>
+          <a:bodyPr/>
+          <a:p/>
+        </p:txBody>
       </p:sp>
       <p:sp>
         <p:nvSpPr>
@@ -7878,6 +7978,10 @@
             <a:prstDash val="solid"/>
           </a:ln>
         </p:spPr>
+        <p:txBody>
+          <a:bodyPr/>
+          <a:p/>
+        </p:txBody>
       </p:sp>
       <p:sp>
         <p:nvSpPr>
@@ -7986,6 +8090,10 @@
             <a:prstDash val="solid"/>
           </a:ln>
         </p:spPr>
+        <p:txBody>
+          <a:bodyPr/>
+          <a:p/>
+        </p:txBody>
       </p:sp>
       <p:sp>
         <p:nvSpPr>
@@ -8094,6 +8202,10 @@
             <a:prstDash val="solid"/>
           </a:ln>
         </p:spPr>
+        <p:txBody>
+          <a:bodyPr/>
+          <a:p/>
+        </p:txBody>
       </p:sp>
       <p:sp>
         <p:nvSpPr>
@@ -8202,6 +8314,10 @@
             <a:prstDash val="solid"/>
           </a:ln>
         </p:spPr>
+        <p:txBody>
+          <a:bodyPr/>
+          <a:p/>
+        </p:txBody>
       </p:sp>
       <p:sp>
         <p:nvSpPr>
@@ -8413,6 +8529,10 @@
           </a:solidFill>
           <a:ln/>
         </p:spPr>
+        <p:txBody>
+          <a:bodyPr/>
+          <a:p/>
+        </p:txBody>
       </p:sp>
       <p:sp>
         <p:nvSpPr>
@@ -8745,6 +8865,10 @@
             <a:prstDash val="solid"/>
           </a:ln>
         </p:spPr>
+        <p:txBody>
+          <a:bodyPr/>
+          <a:p/>
+        </p:txBody>
       </p:sp>
       <p:sp>
         <p:nvSpPr>
@@ -8853,6 +8977,10 @@
             <a:prstDash val="solid"/>
           </a:ln>
         </p:spPr>
+        <p:txBody>
+          <a:bodyPr/>
+          <a:p/>
+        </p:txBody>
       </p:sp>
       <p:sp>
         <p:nvSpPr>
@@ -8961,6 +9089,10 @@
             <a:prstDash val="solid"/>
           </a:ln>
         </p:spPr>
+        <p:txBody>
+          <a:bodyPr/>
+          <a:p/>
+        </p:txBody>
       </p:sp>
       <p:sp>
         <p:nvSpPr>
@@ -9367,7 +9499,7 @@
                 <a:ea typeface="Calibri" pitchFamily="34" charset="-122"/>
                 <a:cs typeface="Calibri" pitchFamily="34" charset="-120"/>
               </a:rPr>
-              <a:t>Se probó y se publicó en PC y Android con controles de teclado/ratón y táctiles.</a:t>
+              <a:t>Se probó y se publicó en Android con controles táctiles.</a:t>
             </a:r>
             <a:endParaRPr lang="en-US" sz="1500" dirty="0"/>
           </a:p>
@@ -9399,6 +9531,10 @@
             <a:prstDash val="solid"/>
           </a:ln>
         </p:spPr>
+        <p:txBody>
+          <a:bodyPr/>
+          <a:p/>
+        </p:txBody>
       </p:sp>
       <p:sp>
         <p:nvSpPr>
@@ -9475,7 +9611,7 @@
                 <a:ea typeface="Calibri" pitchFamily="34" charset="-122"/>
                 <a:cs typeface="Calibri" pitchFamily="34" charset="-120"/>
               </a:rPr>
-              <a:t>Un juego completo, ligero y multiplataforma: 10 etapas × 10 oleadas, 30 enemigos normales y 10 jefes, con capa educativa integrada.</a:t>
+              <a:t>Un juego completo y ligero, pensado para Android: 10 etapas × 10 oleadas, 30 enemigos normales y 10 jefes, con capa educativa integrada.</a:t>
             </a:r>
             <a:endParaRPr lang="en-US" sz="1200" dirty="0"/>
           </a:p>
@@ -9789,6 +9925,78 @@
           </a:p>
         </p:txBody>
       </p:sp>
+      <p:pic>
+        <p:nvPicPr>
+          <p:cNvPr id="7" name="Picture 6" descr="hud.png"/>
+          <p:cNvPicPr>
+            <a:picLocks noChangeAspect="1"/>
+          </p:cNvPicPr>
+          <p:nvPr/>
+        </p:nvPicPr>
+        <p:blipFill>
+          <a:blip r:embed="rId3"/>
+          <a:stretch>
+            <a:fillRect/>
+          </a:stretch>
+        </p:blipFill>
+        <p:spPr>
+          <a:xfrm>
+            <a:off x="749808" y="4434840"/>
+            <a:ext cx="3401568" cy="1913382"/>
+          </a:xfrm>
+          <a:prstGeom prst="rect">
+            <a:avLst/>
+          </a:prstGeom>
+        </p:spPr>
+      </p:pic>
+      <p:pic>
+        <p:nvPicPr>
+          <p:cNvPr id="8" name="Picture 7" descr="cartas.png"/>
+          <p:cNvPicPr>
+            <a:picLocks noChangeAspect="1"/>
+          </p:cNvPicPr>
+          <p:nvPr/>
+        </p:nvPicPr>
+        <p:blipFill>
+          <a:blip r:embed="rId4"/>
+          <a:stretch>
+            <a:fillRect/>
+          </a:stretch>
+        </p:blipFill>
+        <p:spPr>
+          <a:xfrm>
+            <a:off x="4498848" y="4434840"/>
+            <a:ext cx="3401568" cy="1913382"/>
+          </a:xfrm>
+          <a:prstGeom prst="rect">
+            <a:avLst/>
+          </a:prstGeom>
+        </p:spPr>
+      </p:pic>
+      <p:pic>
+        <p:nvPicPr>
+          <p:cNvPr id="9" name="Picture 8" descr="jefe.png"/>
+          <p:cNvPicPr>
+            <a:picLocks noChangeAspect="1"/>
+          </p:cNvPicPr>
+          <p:nvPr/>
+        </p:nvPicPr>
+        <p:blipFill>
+          <a:blip r:embed="rId5"/>
+          <a:stretch>
+            <a:fillRect/>
+          </a:stretch>
+        </p:blipFill>
+        <p:spPr>
+          <a:xfrm>
+            <a:off x="8247888" y="4434840"/>
+            <a:ext cx="3401568" cy="1913382"/>
+          </a:xfrm>
+          <a:prstGeom prst="rect">
+            <a:avLst/>
+          </a:prstGeom>
+        </p:spPr>
+      </p:pic>
     </p:spTree>
   </p:cSld>
   <p:clrMapOvr>
@@ -9842,6 +10050,10 @@
           </a:solidFill>
           <a:ln/>
         </p:spPr>
+        <p:txBody>
+          <a:bodyPr/>
+          <a:p/>
+        </p:txBody>
       </p:sp>
       <p:sp>
         <p:nvSpPr>
@@ -10050,6 +10262,10 @@
           </a:solidFill>
           <a:ln/>
         </p:spPr>
+        <p:txBody>
+          <a:bodyPr/>
+          <a:p/>
+        </p:txBody>
       </p:sp>
       <p:sp>
         <p:nvSpPr>
@@ -10476,6 +10692,10 @@
             <a:prstDash val="solid"/>
           </a:ln>
         </p:spPr>
+        <p:txBody>
+          <a:bodyPr/>
+          <a:p/>
+        </p:txBody>
       </p:sp>
       <p:sp>
         <p:nvSpPr>
@@ -10726,6 +10946,10 @@
           </a:solidFill>
           <a:ln/>
         </p:spPr>
+        <p:txBody>
+          <a:bodyPr/>
+          <a:p/>
+        </p:txBody>
       </p:sp>
       <p:sp>
         <p:nvSpPr>
@@ -11120,7 +11344,7 @@
                 <a:ea typeface="Calibri" pitchFamily="34" charset="-122"/>
                 <a:cs typeface="Calibri" pitchFamily="34" charset="-120"/>
               </a:rPr>
-              <a:t>Godot Engine es libre, ligero y multiplataforma: ideal para un proyecto escolar y para publicar en PC y Android.</a:t>
+              <a:t>Godot Engine es libre y ligero: ideal para un proyecto escolar y para publicar en Android.</a:t>
             </a:r>
             <a:endParaRPr lang="en-US" sz="1500" dirty="0"/>
           </a:p>
@@ -11152,6 +11376,10 @@
             <a:prstDash val="solid"/>
           </a:ln>
         </p:spPr>
+        <p:txBody>
+          <a:bodyPr/>
+          <a:p/>
+        </p:txBody>
       </p:sp>
       <p:sp>
         <p:nvSpPr>
@@ -11260,6 +11488,10 @@
             <a:prstDash val="solid"/>
           </a:ln>
         </p:spPr>
+        <p:txBody>
+          <a:bodyPr/>
+          <a:p/>
+        </p:txBody>
       </p:sp>
       <p:sp>
         <p:nvSpPr>
@@ -11471,6 +11703,10 @@
           </a:solidFill>
           <a:ln/>
         </p:spPr>
+        <p:txBody>
+          <a:bodyPr/>
+          <a:p/>
+        </p:txBody>
       </p:sp>
       <p:sp>
         <p:nvSpPr>
@@ -11803,6 +12039,10 @@
             <a:prstDash val="solid"/>
           </a:ln>
         </p:spPr>
+        <p:txBody>
+          <a:bodyPr/>
+          <a:p/>
+        </p:txBody>
       </p:sp>
       <p:sp>
         <p:nvSpPr>
@@ -12060,6 +12300,10 @@
             <a:prstDash val="solid"/>
           </a:ln>
         </p:spPr>
+        <p:txBody>
+          <a:bodyPr/>
+          <a:p/>
+        </p:txBody>
       </p:sp>
       <p:sp>
         <p:nvSpPr>
@@ -12168,6 +12412,10 @@
             <a:prstDash val="solid"/>
           </a:ln>
         </p:spPr>
+        <p:txBody>
+          <a:bodyPr/>
+          <a:p/>
+        </p:txBody>
       </p:sp>
       <p:sp>
         <p:nvSpPr>
@@ -12276,6 +12524,10 @@
             <a:prstDash val="solid"/>
           </a:ln>
         </p:spPr>
+        <p:txBody>
+          <a:bodyPr/>
+          <a:p/>
+        </p:txBody>
       </p:sp>
       <p:sp>
         <p:nvSpPr>
@@ -12384,6 +12636,10 @@
             <a:prstDash val="solid"/>
           </a:ln>
         </p:spPr>
+        <p:txBody>
+          <a:bodyPr/>
+          <a:p/>
+        </p:txBody>
       </p:sp>
       <p:sp>
         <p:nvSpPr>
@@ -12460,7 +12716,7 @@
                 <a:ea typeface="Calibri" pitchFamily="34" charset="-122"/>
                 <a:cs typeface="Calibri" pitchFamily="34" charset="-120"/>
               </a:rPr>
-              <a:t>Aplicar pruebas finales, ajustes y publicar el juego (PC y Android).</a:t>
+              <a:t>Aplicar pruebas finales, ajustes y publicar el juego en Android.</a:t>
             </a:r>
             <a:endParaRPr lang="en-US" sz="1200" dirty="0"/>
           </a:p>

</xml_diff>